<commit_message>
KN02: Praesentation an echte Testresultate angepasst
</commit_message>
<xml_diff>
--- a/KN02/praesentation/KN02.pptx
+++ b/KN02/praesentation/KN02.pptx
@@ -114,30 +114,30 @@
   <p:extLst>
     <p:ext uri="{521415D9-36F7-43E2-AB2F-B90AF26B5E84}">
       <p14:sectionLst xmlns:p14="http://schemas.microsoft.com/office/powerpoint/2010/main">
-        <p14:section name="Einstieg" id="{ed3016ed-39bc-4bfb-434e-6e2c1c537b81}">
+        <p14:section name="Einstieg" id="{bf616297-b63a-c2c6-2459-f6e5944d6ad2}">
           <p14:sldIdLst>
             <p14:sldId id="256"/>
           </p14:sldIdLst>
         </p14:section>
-        <p14:section name="Übung 1" id="{1be7ca7f-423d-e9c7-dfec-df982bbcf16a}">
+        <p14:section name="Übung 1" id="{4fc99544-1a80-dba8-5de6-c8752191ce66}">
           <p14:sldIdLst>
             <p14:sldId id="257"/>
             <p14:sldId id="258"/>
           </p14:sldIdLst>
         </p14:section>
-        <p14:section name="Übung 2" id="{bbe6be43-00c4-9510-5418-5c9bd86a2fc9}">
+        <p14:section name="Übung 2" id="{03e8147e-9a79-fb4b-f537-e23c2084e630}">
           <p14:sldIdLst>
             <p14:sldId id="259"/>
           </p14:sldIdLst>
         </p14:section>
-        <p14:section name="Übung 3" id="{21d15304-bdee-5f6c-e090-b632b9a963de}">
+        <p14:section name="Übung 3" id="{963fa31e-c990-0d27-c3ce-2ccf443f5d4a}">
           <p14:sldIdLst>
             <p14:sldId id="260"/>
             <p14:sldId id="261"/>
             <p14:sldId id="262"/>
           </p14:sldIdLst>
         </p14:section>
-        <p14:section name="Fazit" id="{b5a06ec4-e670-ce00-1a37-23c49d1a8d54}">
+        <p14:section name="Fazit" id="{bc10462f-66c7-76fe-95d5-e4bfc2f963e9}">
           <p14:sldIdLst>
             <p14:sldId id="263"/>
           </p14:sldIdLst>
@@ -810,7 +810,7 @@
           <a:p>
             <a:r>
               <a:rPr lang="en-US" dirty="0"/>
-              <a:t>Übung 2: Fünf funktionale Black-Box Tests für sixt.ch. Ich kenne den Code nicht, ich teste nur, was ich als Benutzer sehe. Die echte Buchung habe ich nicht durchgeführt, das geht nur auf einer Testumgebung.</a:t>
+              <a:t>Übung 2: Fünf funktionale Black-Box Tests für sixt.ch. Ich kenne den Code nicht, ich teste nur, was ich als Benutzer sehe. Test 2 ist OK: Ein Datum vor der Abholung wird zum neuen Abholdatum. Die Ergebnisliste wurde im automatisierten Browser vom Bot-Schutz blockiert, deshalb sind Test 1, 3 und 4 noch offen. Die echte Buchung geht nur auf einer Testumgebung.</a:t>
             </a:r>
             <a:endParaRPr lang="en-US" dirty="0"/>
           </a:p>
@@ -6384,15 +6384,15 @@
                         <a:buNone/>
                       </a:pPr>
                       <a:r>
-                        <a:rPr lang="en-US" sz="1400" b="1" dirty="0">
+                        <a:rPr lang="en-US" sz="1400" dirty="0">
                           <a:solidFill>
-                            <a:schemeClr val="accent1"/>
+                            <a:schemeClr val="tx1"/>
                           </a:solidFill>
                           <a:latin typeface="Calibri" pitchFamily="34" charset="0"/>
                           <a:ea typeface="Calibri" pitchFamily="34" charset="-122"/>
                           <a:cs typeface="Calibri" pitchFamily="34" charset="-120"/>
                         </a:rPr>
-                        <a:t>OK</a:t>
+                        <a:t>Offen</a:t>
                       </a:r>
                       <a:endParaRPr lang="en-US" sz="1400" dirty="0">
                         <a:latin typeface="Calibri" charset="0"/>
@@ -6598,7 +6598,7 @@
                           <a:ea typeface="Calibri" pitchFamily="34" charset="-122"/>
                           <a:cs typeface="Calibri" pitchFamily="34" charset="-120"/>
                         </a:rPr>
-                        <a:t>Datum gesperrt oder Fehlermeldung</a:t>
+                        <a:t>Rückgabe vor Abholung nicht möglich</a:t>
                       </a:r>
                       <a:endParaRPr lang="en-US" sz="1400" dirty="0">
                         <a:latin typeface="Calibri" charset="0"/>
@@ -6932,15 +6932,15 @@
                         <a:buNone/>
                       </a:pPr>
                       <a:r>
-                        <a:rPr lang="en-US" sz="1400" b="1" dirty="0">
+                        <a:rPr lang="en-US" sz="1400" dirty="0">
                           <a:solidFill>
-                            <a:schemeClr val="accent1"/>
+                            <a:schemeClr val="tx1"/>
                           </a:solidFill>
                           <a:latin typeface="Calibri" pitchFamily="34" charset="0"/>
                           <a:ea typeface="Calibri" pitchFamily="34" charset="-122"/>
                           <a:cs typeface="Calibri" pitchFamily="34" charset="-120"/>
                         </a:rPr>
-                        <a:t>OK</a:t>
+                        <a:t>Offen</a:t>
                       </a:r>
                       <a:endParaRPr lang="en-US" sz="1400" dirty="0">
                         <a:latin typeface="Calibri" charset="0"/>
@@ -7206,15 +7206,15 @@
                         <a:buNone/>
                       </a:pPr>
                       <a:r>
-                        <a:rPr lang="en-US" sz="1400" b="1" dirty="0">
+                        <a:rPr lang="en-US" sz="1400" dirty="0">
                           <a:solidFill>
-                            <a:schemeClr val="accent1"/>
+                            <a:schemeClr val="tx1"/>
                           </a:solidFill>
                           <a:latin typeface="Calibri" pitchFamily="34" charset="0"/>
                           <a:ea typeface="Calibri" pitchFamily="34" charset="-122"/>
                           <a:cs typeface="Calibri" pitchFamily="34" charset="-120"/>
                         </a:rPr>
-                        <a:t>OK</a:t>
+                        <a:t>Offen</a:t>
                       </a:r>
                       <a:endParaRPr lang="en-US" sz="1400" dirty="0">
                         <a:latin typeface="Calibri" charset="0"/>

</xml_diff>